<commit_message>
feat: dashboard with the project's footage statistics; three-presenter demo script
</commit_message>
<xml_diff>
--- a/docs/report/CineMind_AI_Presentation.pptx
+++ b/docs/report/CineMind_AI_Presentation.pptx
@@ -7180,7 +7180,7 @@
       </p:sp>
       <p:pic>
         <p:nvPicPr>
-          <p:cNvPr id="6" name="Image 0" descr="/Volumes/externalssd/cinemind/docs/report/screens/03_library.png">    </p:cNvPr>
+          <p:cNvPr id="6" name="Image 0" descr="/Volumes/externalssd/cinemind/docs/report/screens/01_dashboard.png">    </p:cNvPr>
           <p:cNvPicPr>
             <a:picLocks noChangeAspect="1"/>
           </p:cNvPicPr>
@@ -7194,7 +7194,7 @@
         <p:spPr>
           <a:xfrm>
             <a:off x="7406640" y="1280160"/>
-            <a:ext cx="4480560" cy="2834640"/>
+            <a:ext cx="4480560" cy="3108960"/>
           </a:xfrm>
           <a:prstGeom prst="rect">
             <a:avLst/>

</xml_diff>